<commit_message>
docs: slide de titulo do seminario com autores, orientador e instituicao
Co-Authored-By: Claude Sonnet 5.5 <noreply@anthropic.com>
Claude-Session: https://claude.ai/code/session_01QBooVKGGKQGrenTtP2atqx
</commit_message>
<xml_diff>
--- a/docs/Apresentacao_Seminario_Arcabouco_Auditavel.pptx
+++ b/docs/Apresentacao_Seminario_Arcabouco_Auditavel.pptx
@@ -515,7 +515,7 @@
           <a:p>
             <a:r>
               <a:rPr lang="en-US" dirty="0"/>
-              <a:t>(1 min) Apresentar o tema: não é uma apresentação de resultados, é do arcabouço: como desenhar a amostragem e o teste para que cada número seja rastreável e o critério de sucesso seja fixado antes dos dados. Incluir nome do apresentador e orientação no slide, se for o caso.</a:t>
+              <a:t>(1 min) Apresentar o tema: não é uma apresentação de resultados, é do arcabouço: como desenhar a amostragem e o teste para que cada número seja rastreável e o critério de sucesso seja fixado antes dos dados.</a:t>
             </a:r>
             <a:endParaRPr lang="en-US" dirty="0"/>
           </a:p>
@@ -2040,8 +2040,8 @@
         </p:nvSpPr>
         <p:spPr>
           <a:xfrm>
-            <a:off x="548640" y="1097280"/>
-            <a:ext cx="8046720" cy="1554480"/>
+            <a:off x="548640" y="411480"/>
+            <a:ext cx="8046720" cy="1371600"/>
           </a:xfrm>
           <a:prstGeom prst="rect">
             <a:avLst/>
@@ -2057,7 +2057,7 @@
               <a:buNone/>
             </a:pPr>
             <a:r>
-              <a:rPr lang="en-US" sz="3400" b="1" dirty="0">
+              <a:rPr lang="en-US" sz="3000" b="1" dirty="0">
                 <a:solidFill>
                   <a:srgbClr val="FFFFFF"/>
                 </a:solidFill>
@@ -2067,7 +2067,7 @@
               </a:rPr>
               <a:t>Arcabouço computacional auditável para amostragem estratificada de erosão laminar</a:t>
             </a:r>
-            <a:endParaRPr lang="en-US" sz="3400" dirty="0"/>
+            <a:endParaRPr lang="en-US" sz="3000" dirty="0"/>
           </a:p>
         </p:txBody>
       </p:sp>
@@ -2079,8 +2079,8 @@
         </p:nvSpPr>
         <p:spPr>
           <a:xfrm>
-            <a:off x="548640" y="2880360"/>
-            <a:ext cx="8046720" cy="457200"/>
+            <a:off x="548640" y="1874520"/>
+            <a:ext cx="8046720" cy="411480"/>
           </a:xfrm>
           <a:prstGeom prst="rect">
             <a:avLst/>
@@ -2096,7 +2096,7 @@
               <a:buNone/>
             </a:pPr>
             <a:r>
-              <a:rPr lang="en-US" sz="1800" dirty="0">
+              <a:rPr lang="en-US" sz="1600" dirty="0">
                 <a:solidFill>
                   <a:srgbClr val="8DB596"/>
                 </a:solidFill>
@@ -2106,7 +2106,7 @@
               </a:rPr>
               <a:t>SAREL v2: método, decisões pré-registradas e demonstração do aplicativo</a:t>
             </a:r>
-            <a:endParaRPr lang="en-US" sz="1800" dirty="0"/>
+            <a:endParaRPr lang="en-US" sz="1600" dirty="0"/>
           </a:p>
         </p:txBody>
       </p:sp>
@@ -2118,8 +2118,8 @@
         </p:nvSpPr>
         <p:spPr>
           <a:xfrm>
-            <a:off x="548640" y="4297680"/>
-            <a:ext cx="8046720" cy="365760"/>
+            <a:off x="548640" y="2423160"/>
+            <a:ext cx="8046720" cy="868680"/>
           </a:xfrm>
           <a:prstGeom prst="rect">
             <a:avLst/>
@@ -2135,15 +2135,127 @@
               <a:buNone/>
             </a:pPr>
             <a:r>
-              <a:rPr lang="en-US" sz="1200" dirty="0">
-                <a:solidFill>
-                  <a:srgbClr val="E4E9E3"/>
+              <a:rPr lang="en-US" sz="1400" b="1" dirty="0">
+                <a:solidFill>
+                  <a:srgbClr val="FFFFFF"/>
                 </a:solidFill>
                 <a:latin typeface="Calibri" pitchFamily="34" charset="0"/>
                 <a:ea typeface="Calibri" pitchFamily="34" charset="-122"/>
                 <a:cs typeface="Calibri" pitchFamily="34" charset="-120"/>
               </a:rPr>
-              <a:t>Seminário · Programa de Pós-Graduação em Tecnologias Computacionais para o Agronegócio (PPGTCA) · 2026</a:t>
+              <a:t>Luis Alfredo Ferreira da Silva</a:t>
+            </a:r>
+            <a:endParaRPr lang="en-US" sz="1400" dirty="0"/>
+          </a:p>
+          <a:p>
+            <a:pPr indent="0" marL="0">
+              <a:buNone/>
+            </a:pPr>
+            <a:r>
+              <a:rPr lang="en-US" sz="1400" b="1" dirty="0">
+                <a:solidFill>
+                  <a:srgbClr val="FFFFFF"/>
+                </a:solidFill>
+                <a:latin typeface="Calibri" pitchFamily="34" charset="0"/>
+                <a:ea typeface="Calibri" pitchFamily="34" charset="-122"/>
+                <a:cs typeface="Calibri" pitchFamily="34" charset="-120"/>
+              </a:rPr>
+              <a:t>Fabiana Costa de Araujo Schutz</a:t>
+            </a:r>
+            <a:endParaRPr lang="en-US" sz="1400" dirty="0"/>
+          </a:p>
+          <a:p>
+            <a:pPr indent="0" marL="0">
+              <a:buNone/>
+            </a:pPr>
+            <a:r>
+              <a:rPr lang="en-US" sz="1400" b="1" dirty="0">
+                <a:solidFill>
+                  <a:srgbClr val="FFFFFF"/>
+                </a:solidFill>
+                <a:latin typeface="Calibri" pitchFamily="34" charset="0"/>
+                <a:ea typeface="Calibri" pitchFamily="34" charset="-122"/>
+                <a:cs typeface="Calibri" pitchFamily="34" charset="-120"/>
+              </a:rPr>
+              <a:t>Kiria Vitoria Nakahati</a:t>
+            </a:r>
+            <a:endParaRPr lang="en-US" sz="1400" dirty="0"/>
+          </a:p>
+        </p:txBody>
+      </p:sp>
+      <p:sp>
+        <p:nvSpPr>
+          <p:cNvPr id="5" name="Text 3"/>
+          <p:cNvSpPr txBox="1"/>
+          <p:nvPr/>
+        </p:nvSpPr>
+        <p:spPr>
+          <a:xfrm>
+            <a:off x="548640" y="3429000"/>
+            <a:ext cx="8046720" cy="320040"/>
+          </a:xfrm>
+          <a:prstGeom prst="rect">
+            <a:avLst/>
+          </a:prstGeom>
+          <a:noFill/>
+          <a:ln/>
+        </p:spPr>
+        <p:txBody>
+          <a:bodyPr wrap="square" lIns="0" tIns="0" rIns="0" bIns="0" rtlCol="0" anchor="t"/>
+          <a:lstStyle/>
+          <a:p>
+            <a:pPr indent="0" marL="0">
+              <a:buNone/>
+            </a:pPr>
+            <a:r>
+              <a:rPr lang="en-US" sz="1400" dirty="0">
+                <a:solidFill>
+                  <a:srgbClr val="E4E9E3"/>
+                </a:solidFill>
+                <a:latin typeface="Calibri" pitchFamily="34" charset="0"/>
+                <a:ea typeface="Calibri" pitchFamily="34" charset="-122"/>
+                <a:cs typeface="Calibri" pitchFamily="34" charset="-120"/>
+              </a:rPr>
+              <a:t>Orientador: Claudio Leones Bazzi</a:t>
+            </a:r>
+            <a:endParaRPr lang="en-US" sz="1400" dirty="0"/>
+          </a:p>
+        </p:txBody>
+      </p:sp>
+      <p:sp>
+        <p:nvSpPr>
+          <p:cNvPr id="6" name="Text 4"/>
+          <p:cNvSpPr txBox="1"/>
+          <p:nvPr/>
+        </p:nvSpPr>
+        <p:spPr>
+          <a:xfrm>
+            <a:off x="548640" y="4023360"/>
+            <a:ext cx="8046720" cy="640080"/>
+          </a:xfrm>
+          <a:prstGeom prst="rect">
+            <a:avLst/>
+          </a:prstGeom>
+          <a:noFill/>
+          <a:ln/>
+        </p:spPr>
+        <p:txBody>
+          <a:bodyPr wrap="square" lIns="0" tIns="0" rIns="0" bIns="0" rtlCol="0" anchor="t"/>
+          <a:lstStyle/>
+          <a:p>
+            <a:pPr indent="0" marL="0">
+              <a:buNone/>
+            </a:pPr>
+            <a:r>
+              <a:rPr lang="en-US" sz="1200" dirty="0">
+                <a:solidFill>
+                  <a:srgbClr val="E4E9E3"/>
+                </a:solidFill>
+                <a:latin typeface="Calibri" pitchFamily="34" charset="0"/>
+                <a:ea typeface="Calibri" pitchFamily="34" charset="-122"/>
+                <a:cs typeface="Calibri" pitchFamily="34" charset="-120"/>
+              </a:rPr>
+              <a:t>Programa de Pós-Graduação em Tecnologias Computacionais para o Agronegócio (PPGTCA), Universidade Tecnológica Federal do Paraná (UTFPR), Campus Medianeira</a:t>
             </a:r>
             <a:endParaRPr lang="en-US" sz="1200" dirty="0"/>
           </a:p>

</xml_diff>